<commit_message>
Trying more adjustments for large sets of text
</commit_message>
<xml_diff>
--- a/backend/templates/template2.pptx
+++ b/backend/templates/template2.pptx
@@ -212,7 +212,7 @@
           <a:p>
             <a:fld id="{B56F32FC-4BD9-442A-A8C6-51598C909FE3}" type="datetimeFigureOut">
               <a:rPr lang="en-US" smtClean="0"/>
-              <a:t>1/29/2026</a:t>
+              <a:t>3/2/2026</a:t>
             </a:fld>
             <a:endParaRPr lang="en-US" dirty="0"/>
           </a:p>
@@ -389,7 +389,7 @@
           <a:p>
             <a:fld id="{056371FA-A98D-41E8-93F4-09945841298A}" type="datetimeFigureOut">
               <a:rPr lang="en-US" smtClean="0"/>
-              <a:t>1/29/2026</a:t>
+              <a:t>3/2/2026</a:t>
             </a:fld>
             <a:endParaRPr lang="en-US" dirty="0"/>
           </a:p>
@@ -730,10 +730,10 @@
           <p:nvPr userDrawn="1"/>
         </p:nvPicPr>
         <p:blipFill rotWithShape="1">
-          <a:blip r:embed="rId2">
+          <a:blip>
             <a:extLst>
               <a:ext uri="{96DAC541-7B7A-43D3-8B79-37D633B846F1}">
-                <asvg:svgBlip xmlns:asvg="http://schemas.microsoft.com/office/drawing/2016/SVG/main" r:embed="rId3"/>
+                <asvg:svgBlip xmlns:asvg="http://schemas.microsoft.com/office/drawing/2016/SVG/main" r:embed="rId2"/>
               </a:ext>
             </a:extLst>
           </a:blip>
@@ -1730,10 +1730,10 @@
           <p:nvPr userDrawn="1"/>
         </p:nvPicPr>
         <p:blipFill rotWithShape="1">
-          <a:blip r:embed="rId2">
+          <a:blip>
             <a:extLst>
               <a:ext uri="{96DAC541-7B7A-43D3-8B79-37D633B846F1}">
-                <asvg:svgBlip xmlns:asvg="http://schemas.microsoft.com/office/drawing/2016/SVG/main" r:embed="rId3"/>
+                <asvg:svgBlip xmlns:asvg="http://schemas.microsoft.com/office/drawing/2016/SVG/main" r:embed="rId2"/>
               </a:ext>
             </a:extLst>
           </a:blip>
@@ -2072,6 +2072,335 @@
 </file>
 
 <file path=ppt/slideLayouts/slideLayout13.xml><?xml version="1.0" encoding="utf-8"?>
+<p:sldLayout xmlns:a="http://schemas.openxmlformats.org/drawingml/2006/main" xmlns:r="http://schemas.openxmlformats.org/officeDocument/2006/relationships" xmlns:p="http://schemas.openxmlformats.org/presentationml/2006/main" preserve="1" userDrawn="1">
+  <p:cSld name="Wide Content">
+    <p:bg>
+      <p:bgRef idx="1001">
+        <a:schemeClr val="bg1"/>
+      </p:bgRef>
+    </p:bg>
+    <p:spTree>
+      <p:nvGrpSpPr>
+        <p:cNvPr id="1" name=""/>
+        <p:cNvGrpSpPr/>
+        <p:nvPr/>
+      </p:nvGrpSpPr>
+      <p:grpSpPr>
+        <a:xfrm>
+          <a:off x="0" y="0"/>
+          <a:ext cx="0" cy="0"/>
+          <a:chOff x="0" y="0"/>
+          <a:chExt cx="0" cy="0"/>
+        </a:xfrm>
+      </p:grpSpPr>
+      <p:grpSp>
+        <p:nvGrpSpPr>
+          <p:cNvPr id="10" name="Group 9">
+            <a:extLst>
+              <a:ext uri="{FF2B5EF4-FFF2-40B4-BE49-F238E27FC236}">
+                <a16:creationId xmlns:a16="http://schemas.microsoft.com/office/drawing/2014/main" id="{544E9C70-0200-3C21-7766-CB9EA5FBFA88}"/>
+              </a:ext>
+              <a:ext uri="{C183D7F6-B498-43B3-948B-1728B52AA6E4}">
+                <adec:decorative xmlns:adec="http://schemas.microsoft.com/office/drawing/2017/decorative" val="1"/>
+              </a:ext>
+            </a:extLst>
+          </p:cNvPr>
+          <p:cNvGrpSpPr/>
+          <p:nvPr userDrawn="1"/>
+        </p:nvGrpSpPr>
+        <p:grpSpPr>
+          <a:xfrm>
+            <a:off x="0" y="0"/>
+            <a:ext cx="2590800" cy="1027906"/>
+            <a:chOff x="0" y="0"/>
+            <a:chExt cx="2590800" cy="1027906"/>
+          </a:xfrm>
+        </p:grpSpPr>
+        <p:cxnSp>
+          <p:nvCxnSpPr>
+            <p:cNvPr id="11" name="Straight Connector 10">
+              <a:extLst>
+                <a:ext uri="{FF2B5EF4-FFF2-40B4-BE49-F238E27FC236}">
+                  <a16:creationId xmlns:a16="http://schemas.microsoft.com/office/drawing/2014/main" id="{1D5E4B16-2071-DEE9-BE53-F35AFBEFCA57}"/>
+                </a:ext>
+              </a:extLst>
+            </p:cNvPr>
+            <p:cNvCxnSpPr>
+              <a:cxnSpLocks/>
+            </p:cNvCxnSpPr>
+            <p:nvPr userDrawn="1"/>
+          </p:nvCxnSpPr>
+          <p:spPr>
+            <a:xfrm flipV="1">
+              <a:off x="0" y="0"/>
+              <a:ext cx="2590800" cy="762000"/>
+            </a:xfrm>
+            <a:prstGeom prst="line">
+              <a:avLst/>
+            </a:prstGeom>
+            <a:ln>
+              <a:solidFill>
+                <a:schemeClr val="tx1"/>
+              </a:solidFill>
+            </a:ln>
+          </p:spPr>
+          <p:style>
+            <a:lnRef idx="1">
+              <a:schemeClr val="accent1"/>
+            </a:lnRef>
+            <a:fillRef idx="0">
+              <a:schemeClr val="accent1"/>
+            </a:fillRef>
+            <a:effectRef idx="0">
+              <a:schemeClr val="accent1"/>
+            </a:effectRef>
+            <a:fontRef idx="minor">
+              <a:schemeClr val="tx1"/>
+            </a:fontRef>
+          </p:style>
+        </p:cxnSp>
+        <p:cxnSp>
+          <p:nvCxnSpPr>
+            <p:cNvPr id="12" name="Straight Connector 11">
+              <a:extLst>
+                <a:ext uri="{FF2B5EF4-FFF2-40B4-BE49-F238E27FC236}">
+                  <a16:creationId xmlns:a16="http://schemas.microsoft.com/office/drawing/2014/main" id="{1CB2B071-0355-D550-18A8-9D515CA16987}"/>
+                </a:ext>
+              </a:extLst>
+            </p:cNvPr>
+            <p:cNvCxnSpPr>
+              <a:cxnSpLocks/>
+            </p:cNvCxnSpPr>
+            <p:nvPr userDrawn="1"/>
+          </p:nvCxnSpPr>
+          <p:spPr>
+            <a:xfrm flipH="1">
+              <a:off x="0" y="0"/>
+              <a:ext cx="704850" cy="1027906"/>
+            </a:xfrm>
+            <a:prstGeom prst="line">
+              <a:avLst/>
+            </a:prstGeom>
+            <a:ln>
+              <a:solidFill>
+                <a:schemeClr val="tx1"/>
+              </a:solidFill>
+            </a:ln>
+          </p:spPr>
+          <p:style>
+            <a:lnRef idx="1">
+              <a:schemeClr val="accent1"/>
+            </a:lnRef>
+            <a:fillRef idx="0">
+              <a:schemeClr val="accent1"/>
+            </a:fillRef>
+            <a:effectRef idx="0">
+              <a:schemeClr val="accent1"/>
+            </a:effectRef>
+            <a:fontRef idx="minor">
+              <a:schemeClr val="tx1"/>
+            </a:fontRef>
+          </p:style>
+        </p:cxnSp>
+      </p:grpSp>
+      <p:sp>
+        <p:nvSpPr>
+          <p:cNvPr id="2" name="Title 1">
+            <a:extLst>
+              <a:ext uri="{FF2B5EF4-FFF2-40B4-BE49-F238E27FC236}">
+                <a16:creationId xmlns:a16="http://schemas.microsoft.com/office/drawing/2014/main" id="{EE5C4E19-B78B-4E39-B661-7E6A2E6C5002}"/>
+              </a:ext>
+            </a:extLst>
+          </p:cNvPr>
+          <p:cNvSpPr>
+            <a:spLocks noGrp="1"/>
+          </p:cNvSpPr>
+          <p:nvPr>
+            <p:ph type="title" hasCustomPrompt="1"/>
+          </p:nvPr>
+        </p:nvSpPr>
+        <p:spPr>
+          <a:xfrm>
+            <a:off x="838200" y="353550"/>
+            <a:ext cx="10515600" cy="1325563"/>
+          </a:xfrm>
+        </p:spPr>
+        <p:txBody>
+          <a:bodyPr anchor="b">
+            <a:normAutofit/>
+          </a:bodyPr>
+          <a:lstStyle>
+            <a:lvl1pPr algn="ctr">
+              <a:defRPr lang="en-US" sz="2800" kern="1200" spc="150" baseline="0" dirty="0">
+                <a:solidFill>
+                  <a:schemeClr val="tx1"/>
+                </a:solidFill>
+                <a:latin typeface="+mj-lt"/>
+                <a:ea typeface="+mj-ea"/>
+                <a:cs typeface="+mj-cs"/>
+              </a:defRPr>
+            </a:lvl1pPr>
+          </a:lstStyle>
+          <a:p>
+            <a:r>
+              <a:rPr lang="en-US" dirty="0"/>
+              <a:t>CLICK TO add title</a:t>
+            </a:r>
+          </a:p>
+        </p:txBody>
+      </p:sp>
+      <p:sp>
+        <p:nvSpPr>
+          <p:cNvPr id="6" name="Footer Placeholder 4">
+            <a:extLst>
+              <a:ext uri="{FF2B5EF4-FFF2-40B4-BE49-F238E27FC236}">
+                <a16:creationId xmlns:a16="http://schemas.microsoft.com/office/drawing/2014/main" id="{BFB554B2-4C33-2975-9F27-94B8AE71DF13}"/>
+              </a:ext>
+            </a:extLst>
+          </p:cNvPr>
+          <p:cNvSpPr>
+            <a:spLocks noGrp="1"/>
+          </p:cNvSpPr>
+          <p:nvPr>
+            <p:ph type="ftr" sz="quarter" idx="11"/>
+          </p:nvPr>
+        </p:nvSpPr>
+        <p:spPr>
+          <a:xfrm>
+            <a:off x="838200" y="6356349"/>
+            <a:ext cx="3819228" cy="365125"/>
+          </a:xfrm>
+        </p:spPr>
+        <p:txBody>
+          <a:bodyPr/>
+          <a:lstStyle>
+            <a:lvl1pPr algn="l">
+              <a:defRPr sz="900"/>
+            </a:lvl1pPr>
+          </a:lstStyle>
+          <a:p>
+            <a:r>
+              <a:rPr lang="en-US" dirty="0"/>
+              <a:t>PRESENTATION TITLE</a:t>
+            </a:r>
+          </a:p>
+        </p:txBody>
+      </p:sp>
+      <p:sp>
+        <p:nvSpPr>
+          <p:cNvPr id="7" name="Slide Number Placeholder 5">
+            <a:extLst>
+              <a:ext uri="{FF2B5EF4-FFF2-40B4-BE49-F238E27FC236}">
+                <a16:creationId xmlns:a16="http://schemas.microsoft.com/office/drawing/2014/main" id="{503C6776-E983-2BA3-1054-75996FE0FD22}"/>
+              </a:ext>
+            </a:extLst>
+          </p:cNvPr>
+          <p:cNvSpPr>
+            <a:spLocks noGrp="1"/>
+          </p:cNvSpPr>
+          <p:nvPr>
+            <p:ph type="sldNum" sz="quarter" idx="12"/>
+          </p:nvPr>
+        </p:nvSpPr>
+        <p:spPr>
+          <a:xfrm>
+            <a:off x="10373350" y="6356349"/>
+            <a:ext cx="987552" cy="365125"/>
+          </a:xfrm>
+        </p:spPr>
+        <p:txBody>
+          <a:bodyPr/>
+          <a:lstStyle>
+            <a:lvl1pPr>
+              <a:defRPr sz="900"/>
+            </a:lvl1pPr>
+          </a:lstStyle>
+          <a:p>
+            <a:fld id="{A49DFD55-3C28-40EF-9E31-A92D2E4017FF}" type="slidenum">
+              <a:rPr lang="en-US" smtClean="0"/>
+              <a:pPr/>
+              <a:t>‹#›</a:t>
+            </a:fld>
+            <a:endParaRPr lang="en-US" dirty="0"/>
+          </a:p>
+        </p:txBody>
+      </p:sp>
+      <p:sp>
+        <p:nvSpPr>
+          <p:cNvPr id="14" name="Text Placeholder 13">
+            <a:extLst>
+              <a:ext uri="{FF2B5EF4-FFF2-40B4-BE49-F238E27FC236}">
+                <a16:creationId xmlns:a16="http://schemas.microsoft.com/office/drawing/2014/main" id="{580DD9E7-B5AF-440C-6F77-937A727DC65E}"/>
+              </a:ext>
+            </a:extLst>
+          </p:cNvPr>
+          <p:cNvSpPr>
+            <a:spLocks noGrp="1"/>
+          </p:cNvSpPr>
+          <p:nvPr>
+            <p:ph type="body" sz="quarter" idx="13"/>
+          </p:nvPr>
+        </p:nvSpPr>
+        <p:spPr>
+          <a:xfrm>
+            <a:off x="838200" y="1838325"/>
+            <a:ext cx="10515600" cy="4407362"/>
+          </a:xfrm>
+        </p:spPr>
+        <p:txBody>
+          <a:bodyPr/>
+          <a:lstStyle/>
+          <a:p>
+            <a:pPr lvl="0"/>
+            <a:r>
+              <a:rPr lang="en-US"/>
+              <a:t>Click to edit Master text styles</a:t>
+            </a:r>
+          </a:p>
+          <a:p>
+            <a:pPr lvl="1"/>
+            <a:r>
+              <a:rPr lang="en-US"/>
+              <a:t>Second level</a:t>
+            </a:r>
+          </a:p>
+          <a:p>
+            <a:pPr lvl="2"/>
+            <a:r>
+              <a:rPr lang="en-US"/>
+              <a:t>Third level</a:t>
+            </a:r>
+          </a:p>
+          <a:p>
+            <a:pPr lvl="3"/>
+            <a:r>
+              <a:rPr lang="en-US"/>
+              <a:t>Fourth level</a:t>
+            </a:r>
+          </a:p>
+          <a:p>
+            <a:pPr lvl="4"/>
+            <a:r>
+              <a:rPr lang="en-US"/>
+              <a:t>Fifth level</a:t>
+            </a:r>
+          </a:p>
+        </p:txBody>
+      </p:sp>
+    </p:spTree>
+    <p:extLst>
+      <p:ext uri="{BB962C8B-B14F-4D97-AF65-F5344CB8AC3E}">
+        <p14:creationId xmlns:p14="http://schemas.microsoft.com/office/powerpoint/2010/main" val="4276895688"/>
+      </p:ext>
+    </p:extLst>
+  </p:cSld>
+  <p:clrMapOvr>
+    <a:overrideClrMapping bg1="lt1" tx1="dk1" bg2="lt2" tx2="dk2" accent1="accent1" accent2="accent2" accent3="accent3" accent4="accent4" accent5="accent5" accent6="accent6" hlink="hlink" folHlink="folHlink"/>
+  </p:clrMapOvr>
+</p:sldLayout>
+</file>
+
+<file path=ppt/slideLayouts/slideLayout14.xml><?xml version="1.0" encoding="utf-8"?>
 <p:sldLayout xmlns:a="http://schemas.openxmlformats.org/drawingml/2006/main" xmlns:r="http://schemas.openxmlformats.org/officeDocument/2006/relationships" xmlns:p="http://schemas.openxmlformats.org/presentationml/2006/main" type="title" preserve="1">
   <p:cSld name="Closing">
     <p:bg>
@@ -2236,10 +2565,10 @@
           <p:nvPr userDrawn="1"/>
         </p:nvPicPr>
         <p:blipFill>
-          <a:blip r:embed="rId2">
+          <a:blip>
             <a:extLst>
               <a:ext uri="{96DAC541-7B7A-43D3-8B79-37D633B846F1}">
-                <asvg:svgBlip xmlns:asvg="http://schemas.microsoft.com/office/drawing/2016/SVG/main" r:embed="rId3"/>
+                <asvg:svgBlip xmlns:asvg="http://schemas.microsoft.com/office/drawing/2016/SVG/main" r:embed="rId2"/>
               </a:ext>
             </a:extLst>
           </a:blip>
@@ -2389,10 +2718,10 @@
           <p:nvPr userDrawn="1"/>
         </p:nvPicPr>
         <p:blipFill rotWithShape="1">
-          <a:blip r:embed="rId2">
+          <a:blip>
             <a:extLst>
               <a:ext uri="{96DAC541-7B7A-43D3-8B79-37D633B846F1}">
-                <asvg:svgBlip xmlns:asvg="http://schemas.microsoft.com/office/drawing/2016/SVG/main" r:embed="rId3"/>
+                <asvg:svgBlip xmlns:asvg="http://schemas.microsoft.com/office/drawing/2016/SVG/main" r:embed="rId2"/>
               </a:ext>
             </a:extLst>
           </a:blip>
@@ -3632,10 +3961,10 @@
           <p:nvPr userDrawn="1"/>
         </p:nvPicPr>
         <p:blipFill>
-          <a:blip r:embed="rId2">
+          <a:blip>
             <a:extLst>
               <a:ext uri="{96DAC541-7B7A-43D3-8B79-37D633B846F1}">
-                <asvg:svgBlip xmlns:asvg="http://schemas.microsoft.com/office/drawing/2016/SVG/main" r:embed="rId3"/>
+                <asvg:svgBlip xmlns:asvg="http://schemas.microsoft.com/office/drawing/2016/SVG/main" r:embed="rId2"/>
               </a:ext>
             </a:extLst>
           </a:blip>
@@ -3709,10 +4038,10 @@
           <p:nvPr userDrawn="1"/>
         </p:nvPicPr>
         <p:blipFill rotWithShape="1">
-          <a:blip r:embed="rId2">
+          <a:blip>
             <a:extLst>
               <a:ext uri="{96DAC541-7B7A-43D3-8B79-37D633B846F1}">
-                <asvg:svgBlip xmlns:asvg="http://schemas.microsoft.com/office/drawing/2016/SVG/main" r:embed="rId3"/>
+                <asvg:svgBlip xmlns:asvg="http://schemas.microsoft.com/office/drawing/2016/SVG/main" r:embed="rId2"/>
               </a:ext>
             </a:extLst>
           </a:blip>
@@ -5714,7 +6043,8 @@
     <p:sldLayoutId id="2147483674" r:id="rId10"/>
     <p:sldLayoutId id="2147483653" r:id="rId11"/>
     <p:sldLayoutId id="2147483667" r:id="rId12"/>
-    <p:sldLayoutId id="2147483665" r:id="rId13"/>
+    <p:sldLayoutId id="2147483675" r:id="rId13"/>
+    <p:sldLayoutId id="2147483665" r:id="rId14"/>
   </p:sldLayoutIdLst>
   <p:hf hdr="0" ftr="0" dt="0"/>
   <p:txStyles>
@@ -6801,6 +7131,26 @@
 </file>
 
 <file path=customXml/item2.xml><?xml version="1.0" encoding="utf-8"?>
+<p:properties xmlns:p="http://schemas.microsoft.com/office/2006/metadata/properties" xmlns:xsi="http://www.w3.org/2001/XMLSchema-instance" xmlns:pc="http://schemas.microsoft.com/office/infopath/2007/PartnerControls">
+  <documentManagement>
+    <_ip_UnifiedCompliancePolicyUIAction xmlns="http://schemas.microsoft.com/sharepoint/v3" xsi:nil="true"/>
+    <Image xmlns="71af3243-3dd4-4a8d-8c0d-dd76da1f02a5">
+      <Url xsi:nil="true"/>
+      <Description xsi:nil="true"/>
+    </Image>
+    <Status xmlns="71af3243-3dd4-4a8d-8c0d-dd76da1f02a5">Not started</Status>
+    <Background xmlns="71af3243-3dd4-4a8d-8c0d-dd76da1f02a5">false</Background>
+    <_ip_UnifiedCompliancePolicyProperties xmlns="http://schemas.microsoft.com/sharepoint/v3" xsi:nil="true"/>
+    <ImageTagsTaxHTField xmlns="71af3243-3dd4-4a8d-8c0d-dd76da1f02a5">
+      <Terms xmlns="http://schemas.microsoft.com/office/infopath/2007/PartnerControls"/>
+    </ImageTagsTaxHTField>
+    <TaxCatchAll xmlns="230e9df3-be65-4c73-a93b-d1236ebd677e" xsi:nil="true"/>
+    <MediaServiceKeyPoints xmlns="71af3243-3dd4-4a8d-8c0d-dd76da1f02a5" xsi:nil="true"/>
+  </documentManagement>
+</p:properties>
+</file>
+
+<file path=customXml/item3.xml><?xml version="1.0" encoding="utf-8"?>
 <ct:contentTypeSchema xmlns:ct="http://schemas.microsoft.com/office/2006/metadata/contentType" xmlns:ma="http://schemas.microsoft.com/office/2006/metadata/properties/metaAttributes" ct:_="" ma:_="" ma:contentTypeName="Document" ma:contentTypeID="0x01010079F111ED35F8CC479449609E8A0923A6" ma:contentTypeVersion="28" ma:contentTypeDescription="Create a new document." ma:contentTypeScope="" ma:versionID="60f5a4f2d2b0abadcf532d48ebf9cb71">
   <xsd:schema xmlns:xsd="http://www.w3.org/2001/XMLSchema" xmlns:xs="http://www.w3.org/2001/XMLSchema" xmlns:p="http://schemas.microsoft.com/office/2006/metadata/properties" xmlns:ns1="http://schemas.microsoft.com/sharepoint/v3" xmlns:ns2="71af3243-3dd4-4a8d-8c0d-dd76da1f02a5" xmlns:ns3="16c05727-aa75-4e4a-9b5f-8a80a1165891" xmlns:ns4="230e9df3-be65-4c73-a93b-d1236ebd677e" targetNamespace="http://schemas.microsoft.com/office/2006/metadata/properties" ma:root="true" ma:fieldsID="7dd78129e6a1811f84807ad11c651531" ns1:_="" ns2:_="" ns3:_="" ns4:_="">
     <xsd:import namespace="http://schemas.microsoft.com/sharepoint/v3"/>
@@ -7112,26 +7462,6 @@
 </ct:contentTypeSchema>
 </file>
 
-<file path=customXml/item3.xml><?xml version="1.0" encoding="utf-8"?>
-<p:properties xmlns:p="http://schemas.microsoft.com/office/2006/metadata/properties" xmlns:xsi="http://www.w3.org/2001/XMLSchema-instance" xmlns:pc="http://schemas.microsoft.com/office/infopath/2007/PartnerControls">
-  <documentManagement>
-    <_ip_UnifiedCompliancePolicyUIAction xmlns="http://schemas.microsoft.com/sharepoint/v3" xsi:nil="true"/>
-    <Image xmlns="71af3243-3dd4-4a8d-8c0d-dd76da1f02a5">
-      <Url xsi:nil="true"/>
-      <Description xsi:nil="true"/>
-    </Image>
-    <Status xmlns="71af3243-3dd4-4a8d-8c0d-dd76da1f02a5">Not started</Status>
-    <Background xmlns="71af3243-3dd4-4a8d-8c0d-dd76da1f02a5">false</Background>
-    <_ip_UnifiedCompliancePolicyProperties xmlns="http://schemas.microsoft.com/sharepoint/v3" xsi:nil="true"/>
-    <ImageTagsTaxHTField xmlns="71af3243-3dd4-4a8d-8c0d-dd76da1f02a5">
-      <Terms xmlns="http://schemas.microsoft.com/office/infopath/2007/PartnerControls"/>
-    </ImageTagsTaxHTField>
-    <TaxCatchAll xmlns="230e9df3-be65-4c73-a93b-d1236ebd677e" xsi:nil="true"/>
-    <MediaServiceKeyPoints xmlns="71af3243-3dd4-4a8d-8c0d-dd76da1f02a5" xsi:nil="true"/>
-  </documentManagement>
-</p:properties>
-</file>
-
 <file path=customXml/itemProps1.xml><?xml version="1.0" encoding="utf-8"?>
 <ds:datastoreItem xmlns:ds="http://schemas.openxmlformats.org/officeDocument/2006/customXml" ds:itemID="{CABF691C-888B-4061-8A6F-D5CE84A0254B}">
   <ds:schemaRefs>
@@ -7141,6 +7471,18 @@
 </file>
 
 <file path=customXml/itemProps2.xml><?xml version="1.0" encoding="utf-8"?>
+<ds:datastoreItem xmlns:ds="http://schemas.openxmlformats.org/officeDocument/2006/customXml" ds:itemID="{49168DCE-134F-4610-A6AA-88CEBE8D71D2}">
+  <ds:schemaRefs>
+    <ds:schemaRef ds:uri="http://schemas.microsoft.com/office/2006/metadata/properties"/>
+    <ds:schemaRef ds:uri="http://schemas.microsoft.com/office/infopath/2007/PartnerControls"/>
+    <ds:schemaRef ds:uri="http://schemas.microsoft.com/sharepoint/v3"/>
+    <ds:schemaRef ds:uri="71af3243-3dd4-4a8d-8c0d-dd76da1f02a5"/>
+    <ds:schemaRef ds:uri="230e9df3-be65-4c73-a93b-d1236ebd677e"/>
+  </ds:schemaRefs>
+</ds:datastoreItem>
+</file>
+
+<file path=customXml/itemProps3.xml><?xml version="1.0" encoding="utf-8"?>
 <ds:datastoreItem xmlns:ds="http://schemas.openxmlformats.org/officeDocument/2006/customXml" ds:itemID="{5EDE3176-A15D-46A3-BDDB-64A0D7363224}">
   <ds:schemaRefs>
     <ds:schemaRef ds:uri="http://schemas.microsoft.com/office/2006/metadata/contentType"/>
@@ -7161,18 +7503,6 @@
 </ds:datastoreItem>
 </file>
 
-<file path=customXml/itemProps3.xml><?xml version="1.0" encoding="utf-8"?>
-<ds:datastoreItem xmlns:ds="http://schemas.openxmlformats.org/officeDocument/2006/customXml" ds:itemID="{49168DCE-134F-4610-A6AA-88CEBE8D71D2}">
-  <ds:schemaRefs>
-    <ds:schemaRef ds:uri="http://schemas.microsoft.com/office/2006/metadata/properties"/>
-    <ds:schemaRef ds:uri="http://schemas.microsoft.com/office/infopath/2007/PartnerControls"/>
-    <ds:schemaRef ds:uri="http://schemas.microsoft.com/sharepoint/v3"/>
-    <ds:schemaRef ds:uri="71af3243-3dd4-4a8d-8c0d-dd76da1f02a5"/>
-    <ds:schemaRef ds:uri="230e9df3-be65-4c73-a93b-d1236ebd677e"/>
-  </ds:schemaRefs>
-</ds:datastoreItem>
-</file>
-
 <file path=docMetadata/LabelInfo.xml><?xml version="1.0" encoding="utf-8"?>
 <clbl:labelList xmlns:clbl="http://schemas.microsoft.com/office/2020/mipLabelMetadata">
   <clbl:label id="{f42aa342-8706-4288-bd11-ebb85995028c}" enabled="1" method="Standard" siteId="{72f988bf-86f1-41af-91ab-2d7cd011db47}" contentBits="0" removed="0"/>

</xml_diff>